<commit_message>
fix(pptx): treat a picture fill as ink when a shape casts a shadow
- A picture-filled shape resolves `fill: None`, so the shadow filter dropped its
  effect list before `picture_filled` could carry it into the image rewrite;
  both the edited-model and snapshot-node paths now count a resolved picture
  fill as ink.
- Cover the paths the change adds: a picture-filled shape and a graphic frame's
  OLE fallback picture in the repro fixture, an alpha-silhouette golden, the
  byte-for-byte match with the shape-shadow path on an opaque source, and the
  per-slide shadow budget in both backends.

Co-Authored-By: Claude Opus 5 <noreply@anthropic.com>
</commit_message>
<xml_diff>
--- a/crates/pptx-render/tests/fixtures/outer-shadow-picture.pptx
+++ b/crates/pptx-render/tests/fixtures/outer-shadow-picture.pptx
@@ -122,6 +122,85 @@
           </a:prstGeom>
         </p:spPr>
       </p:pic>
+      <p:sp>
+        <p:nvSpPr>
+          <p:cNvPr id="6" name="Picture-filled card"/>
+          <p:cNvSpPr/>
+          <p:nvPr/>
+        </p:nvSpPr>
+        <p:spPr>
+          <a:xfrm>
+            <a:off x="1524000" y="4191000"/>
+            <a:ext cx="2286000" cy="2286000"/>
+          </a:xfrm>
+          <a:prstGeom prst="rect">
+            <a:avLst/>
+          </a:prstGeom>
+          <a:blipFill>
+            <a:blip r:embed="rId2"/>
+            <a:stretch>
+              <a:fillRect/>
+            </a:stretch>
+          </a:blipFill>
+          <a:ln>
+            <a:noFill/>
+          </a:ln>
+          <a:effectLst>
+            <a:outerShdw blurRad="76200" dist="38100" dir="2700000" rotWithShape="0">
+              <a:prstClr val="black">
+                <a:alpha val="40000"/>
+              </a:prstClr>
+            </a:outerShdw>
+          </a:effectLst>
+        </p:spPr>
+      </p:sp>
+      <p:graphicFrame>
+        <p:nvGraphicFramePr>
+          <p:cNvPr id="7" name="OLE mark"/>
+          <p:cNvGraphicFramePr/>
+          <p:nvPr/>
+        </p:nvGraphicFramePr>
+        <p:xfrm>
+          <a:off x="6096000" y="4191000"/>
+          <a:ext cx="2286000" cy="2286000"/>
+        </p:xfrm>
+        <a:graphic>
+          <a:graphicData uri="http://schemas.openxmlformats.org/presentationml/2006/ole">
+            <p:oleObj r:id="rId2">
+              <p:embed/>
+              <p:pic>
+                <p:nvPicPr>
+                  <p:cNvPr id="8" name="OLE fallback"/>
+                  <p:cNvPicPr/>
+                  <p:nvPr/>
+                </p:nvPicPr>
+                <p:blipFill>
+                  <a:blip r:embed="rId2"/>
+                  <a:stretch>
+                    <a:fillRect/>
+                  </a:stretch>
+                </p:blipFill>
+                <p:spPr>
+                  <a:xfrm>
+                    <a:off x="0" y="0"/>
+                    <a:ext cx="2286000" cy="2286000"/>
+                  </a:xfrm>
+                  <a:prstGeom prst="rect">
+                    <a:avLst/>
+                  </a:prstGeom>
+                  <a:effectLst>
+                    <a:outerShdw blurRad="76200" dist="38100" dir="2700000" rotWithShape="0">
+                      <a:prstClr val="black">
+                        <a:alpha val="40000"/>
+                      </a:prstClr>
+                    </a:outerShdw>
+                  </a:effectLst>
+                </p:spPr>
+              </p:pic>
+            </p:oleObj>
+          </a:graphicData>
+        </a:graphic>
+      </p:graphicFrame>
     </p:spTree>
   </p:cSld>
 </p:sld>

</xml_diff>